<commit_message>
Simplify project wording and refresh submission documents
</commit_message>
<xml_diff>
--- a/deliverables/Douglas_Bobeck_ANA500_Micro_Project_1.pptx
+++ b/deliverables/Douglas_Bobeck_ANA500_Micro_Project_1.pptx
@@ -2,19 +2,19 @@
 <file path=ppt/presentation.xml><?xml version="1.0" encoding="utf-8"?>
 <p:presentation xmlns:p="http://schemas.openxmlformats.org/presentationml/2006/main">
   <p:sldMasterIdLst>
-    <p:sldMasterId xmlns:r="http://schemas.openxmlformats.org/officeDocument/2006/relationships" id="2147483648" r:id="R0da183c9f15c4a06"/>
+    <p:sldMasterId xmlns:r="http://schemas.openxmlformats.org/officeDocument/2006/relationships" id="2147483648" r:id="R3504c176dd0344c3"/>
   </p:sldMasterIdLst>
   <p:notesMasterIdLst>
-    <p:notesMasterId xmlns:r="http://schemas.openxmlformats.org/officeDocument/2006/relationships" r:id="Rba90f96645f34bb2"/>
+    <p:notesMasterId xmlns:r="http://schemas.openxmlformats.org/officeDocument/2006/relationships" r:id="R5a24f07945314ee2"/>
   </p:notesMasterIdLst>
   <p:sldIdLst>
-    <p:sldId xmlns:r="http://schemas.openxmlformats.org/officeDocument/2006/relationships" id="256" r:id="R6f508ad22c294d80"/>
-    <p:sldId xmlns:r="http://schemas.openxmlformats.org/officeDocument/2006/relationships" id="257" r:id="Rafaa3ab7ea574ac4"/>
-    <p:sldId xmlns:r="http://schemas.openxmlformats.org/officeDocument/2006/relationships" id="258" r:id="R0f489e16030548b0"/>
-    <p:sldId xmlns:r="http://schemas.openxmlformats.org/officeDocument/2006/relationships" id="259" r:id="R6fdcf017cdfb4f68"/>
-    <p:sldId xmlns:r="http://schemas.openxmlformats.org/officeDocument/2006/relationships" id="260" r:id="R689be0b4fec9424b"/>
-    <p:sldId xmlns:r="http://schemas.openxmlformats.org/officeDocument/2006/relationships" id="261" r:id="R54cfeac5251848e1"/>
-    <p:sldId xmlns:r="http://schemas.openxmlformats.org/officeDocument/2006/relationships" id="262" r:id="R9e2a4e499a0847f6"/>
+    <p:sldId xmlns:r="http://schemas.openxmlformats.org/officeDocument/2006/relationships" id="256" r:id="R92d6da84e3df4182"/>
+    <p:sldId xmlns:r="http://schemas.openxmlformats.org/officeDocument/2006/relationships" id="257" r:id="Rcfa26df8a52a44f7"/>
+    <p:sldId xmlns:r="http://schemas.openxmlformats.org/officeDocument/2006/relationships" id="258" r:id="Rb84f866801d54a2d"/>
+    <p:sldId xmlns:r="http://schemas.openxmlformats.org/officeDocument/2006/relationships" id="259" r:id="Rcdf36fd4ef4a4d95"/>
+    <p:sldId xmlns:r="http://schemas.openxmlformats.org/officeDocument/2006/relationships" id="260" r:id="Rfbe48cb79ddd4495"/>
+    <p:sldId xmlns:r="http://schemas.openxmlformats.org/officeDocument/2006/relationships" id="261" r:id="R7c550bba107545b1"/>
+    <p:sldId xmlns:r="http://schemas.openxmlformats.org/officeDocument/2006/relationships" id="262" r:id="Ra991f63e70d94814"/>
   </p:sldIdLst>
   <p:sldSz cx="12192000" cy="6858000"/>
   <p:notesSz cx="6858000" cy="9144000"/>
@@ -988,7 +988,7 @@
           </a:p>
           <a:p xmlns:a="http://schemas.openxmlformats.org/drawingml/2006/main">
             <a:r>
-              <a:t>The final code document includes the executed script, detailed comments, actual output, and interpretation of preparation choices. Readiness applies to the defined education-income comparison, not every possible analysis using this dataset.</a:t>
+              <a:t>The Python code and output PDF includes the full script, comments explaining each section, output, and the reasons for the cleaning decisions. A later analysis would need to decide how to handle survey weights and missing values in any additional variables.</a:t>
             </a:r>
           </a:p>
         </p:txBody>
@@ -3797,17 +3797,17 @@
   </p:cSld>
   <p:clrMap bg1="lt1" tx1="dk1" bg2="lt2" tx2="dk2" accent1="accent1" accent2="accent2" accent3="accent3" accent4="accent4" accent5="accent5" accent6="accent6" hlink="hlink" folHlink="folHlink"/>
   <p:sldLayoutIdLst>
-    <p:sldLayoutId xmlns:r="http://schemas.openxmlformats.org/officeDocument/2006/relationships" id="2147483649" r:id="Rb17e4b2d045c4fad"/>
-    <p:sldLayoutId xmlns:r="http://schemas.openxmlformats.org/officeDocument/2006/relationships" id="2147483650" r:id="R2c810f244cbe42dd"/>
-    <p:sldLayoutId xmlns:r="http://schemas.openxmlformats.org/officeDocument/2006/relationships" id="2147483651" r:id="Rf66f9796b6124f07"/>
-    <p:sldLayoutId xmlns:r="http://schemas.openxmlformats.org/officeDocument/2006/relationships" id="2147483652" r:id="Ra91f1d9095334a9f"/>
-    <p:sldLayoutId xmlns:r="http://schemas.openxmlformats.org/officeDocument/2006/relationships" id="2147483653" r:id="R7725904521614522"/>
-    <p:sldLayoutId xmlns:r="http://schemas.openxmlformats.org/officeDocument/2006/relationships" id="2147483654" r:id="Rcbf22c55299e4278"/>
-    <p:sldLayoutId xmlns:r="http://schemas.openxmlformats.org/officeDocument/2006/relationships" id="2147483655" r:id="R06613c8a9b0b4415"/>
-    <p:sldLayoutId xmlns:r="http://schemas.openxmlformats.org/officeDocument/2006/relationships" id="2147483656" r:id="R0973e6175d6e484a"/>
-    <p:sldLayoutId xmlns:r="http://schemas.openxmlformats.org/officeDocument/2006/relationships" id="2147483657" r:id="R3feac4e7803f4c01"/>
-    <p:sldLayoutId xmlns:r="http://schemas.openxmlformats.org/officeDocument/2006/relationships" id="2147483658" r:id="Ra7d6ccacf93b49d7"/>
-    <p:sldLayoutId xmlns:r="http://schemas.openxmlformats.org/officeDocument/2006/relationships" id="2147483659" r:id="R1dfd4862b9e94d3c"/>
+    <p:sldLayoutId xmlns:r="http://schemas.openxmlformats.org/officeDocument/2006/relationships" id="2147483649" r:id="Rd6194d3a089d433d"/>
+    <p:sldLayoutId xmlns:r="http://schemas.openxmlformats.org/officeDocument/2006/relationships" id="2147483650" r:id="R75e5700facd742ad"/>
+    <p:sldLayoutId xmlns:r="http://schemas.openxmlformats.org/officeDocument/2006/relationships" id="2147483651" r:id="Rea19f176346844c7"/>
+    <p:sldLayoutId xmlns:r="http://schemas.openxmlformats.org/officeDocument/2006/relationships" id="2147483652" r:id="R1fdb54cf8ecb4aea"/>
+    <p:sldLayoutId xmlns:r="http://schemas.openxmlformats.org/officeDocument/2006/relationships" id="2147483653" r:id="Rbfa7a3a80d874f7f"/>
+    <p:sldLayoutId xmlns:r="http://schemas.openxmlformats.org/officeDocument/2006/relationships" id="2147483654" r:id="R4c2dda50e1df4780"/>
+    <p:sldLayoutId xmlns:r="http://schemas.openxmlformats.org/officeDocument/2006/relationships" id="2147483655" r:id="R66c7c301f7934a22"/>
+    <p:sldLayoutId xmlns:r="http://schemas.openxmlformats.org/officeDocument/2006/relationships" id="2147483656" r:id="R57d0b8450d2a4084"/>
+    <p:sldLayoutId xmlns:r="http://schemas.openxmlformats.org/officeDocument/2006/relationships" id="2147483657" r:id="Ra1d65918e5b54162"/>
+    <p:sldLayoutId xmlns:r="http://schemas.openxmlformats.org/officeDocument/2006/relationships" id="2147483658" r:id="Rae6c7a80d9ba4d2c"/>
+    <p:sldLayoutId xmlns:r="http://schemas.openxmlformats.org/officeDocument/2006/relationships" id="2147483659" r:id="R4936b75682db426a"/>
   </p:sldLayoutIdLst>
   <p:txStyles>
     <p:titleStyle>
@@ -4443,7 +4443,7 @@
                 <a:latin typeface="Calibri Light"/>
                 <a:ea typeface="Calibri Light"/>
                 <a:cs typeface="Calibri Light"/>
-                <a:hlinkClick xmlns:r="http://schemas.openxmlformats.org/officeDocument/2006/relationships" r:id="Rf37af65d97fd4cce"/>
+                <a:hlinkClick xmlns:r="http://schemas.openxmlformats.org/officeDocument/2006/relationships" r:id="Re10c9a4e07f646f0"/>
               </a:rPr>
               <a:t>github.com/mascon0423/ANA500</a:t>
             </a:r>
@@ -4578,7 +4578,7 @@
                 <a:ea typeface="Times New Roman"/>
                 <a:cs typeface="Times New Roman"/>
               </a:rPr>
-              <a:t>This project investigates how income category varies with educational attainment in the Adult census sample.</a:t>
+              <a:t>This project looks at the relationship between education and income in the Adult dataset.</a:t>
             </a:r>
           </a:p>
           <a:p xmlns:a="http://schemas.openxmlformats.org/drawingml/2006/main">
@@ -4634,7 +4634,7 @@
                 <a:ea typeface="Times New Roman"/>
                 <a:cs typeface="Times New Roman"/>
               </a:rPr>
-              <a:t>The outcome is an annual income category: at or below $50,000 versus above $50,000. Exact salaries are unavailable.</a:t>
+              <a:t>Income is recorded in two groups: at or below $50,000 per year and above $50,000. The dataset does not give exact incomes.</a:t>
             </a:r>
           </a:p>
           <a:p xmlns:a="http://schemas.openxmlformats.org/drawingml/2006/main">
@@ -4662,7 +4662,7 @@
                 <a:ea typeface="Times New Roman"/>
                 <a:cs typeface="Times New Roman"/>
               </a:rPr>
-              <a:t>Micro-Project 1 establishes the question and prepares the data for a later comparison.</a:t>
+              <a:t>The work for this week is to load, explore, and clean the data so it can be used for a later comparison.</a:t>
             </a:r>
           </a:p>
         </p:txBody>
@@ -4763,7 +4763,7 @@
                 <a:ea typeface="Times New Roman"/>
                 <a:cs typeface="Times New Roman"/>
               </a:rPr>
-              <a:t>Hypothesis: The bachelor's-or-higher group has a greater share of adults earning above $50,000 than the group below a bachelor's degree.</a:t>
+              <a:t>Hypothesis: Adults with at least a bachelor's degree are more likely to earn above $50,000 than adults with less education.</a:t>
             </a:r>
           </a:p>
           <a:p xmlns:a="http://schemas.openxmlformats.org/drawingml/2006/main">
@@ -4791,7 +4791,7 @@
                 <a:ea typeface="Times New Roman"/>
                 <a:cs typeface="Times New Roman"/>
               </a:rPr>
-              <a:t>Possible explanation: Higher educational attainment may provide access to occupations with higher earnings. This is a proposed explanation, not a finding.</a:t>
+              <a:t>Possible explanation: More education may help people qualify for jobs with higher pay. This explanation would need to be tested.</a:t>
             </a:r>
           </a:p>
           <a:p xmlns:a="http://schemas.openxmlformats.org/drawingml/2006/main">
@@ -4819,7 +4819,7 @@
                 <a:ea typeface="Times New Roman"/>
                 <a:cs typeface="Times New Roman"/>
               </a:rPr>
-              <a:t>Bachelor's or higher includes Bachelors, Masters, Prof-school, and Doctorate. All other education categories form the comparison group.</a:t>
+              <a:t>The degree group includes Bachelors, Masters, Prof-school, and Doctorate. The comparison group includes all other education levels.</a:t>
             </a:r>
           </a:p>
           <a:p xmlns:a="http://schemas.openxmlformats.org/drawingml/2006/main">
@@ -4847,7 +4847,7 @@
                 <a:ea typeface="Times New Roman"/>
                 <a:cs typeface="Times New Roman"/>
               </a:rPr>
-              <a:t>The hypothesis remains untested. Age, occupation, and work hours could also influence the observed relationship.</a:t>
+              <a:t>Age, occupation, and hours worked may also affect income. This week's project prepares the data and leaves the hypothesis untested.</a:t>
             </a:r>
           </a:p>
         </p:txBody>
@@ -5032,7 +5032,7 @@
                 <a:ea typeface="Times New Roman"/>
                 <a:cs typeface="Times New Roman"/>
               </a:rPr>
-              <a:t>Pandas loads the local CSV as a DataFrame. One row represents an adult record. The original file is preserved.</a:t>
+              <a:t>Tools used: Python in PyCharm, Pandas to load and organize the CSV as a DataFrame, and NumPy for numerical operations. The original CSV is kept unchanged.</a:t>
             </a:r>
           </a:p>
           <a:p xmlns:a="http://schemas.openxmlformats.org/drawingml/2006/main">
@@ -5060,7 +5060,7 @@
                 <a:ea typeface="Times New Roman"/>
                 <a:cs typeface="Times New Roman"/>
               </a:rPr>
-              <a:t>Key fields are education, education-num, and income. Age, work hours, and occupation provide context. fnlwgt is a survey weight, not a person ID.</a:t>
+              <a:t>The main fields are education, education-num, and income. Age, occupation, and hours worked add context. fnlwgt is the final survey weight.</a:t>
             </a:r>
           </a:p>
           <a:p xmlns:a="http://schemas.openxmlformats.org/drawingml/2006/main">
@@ -5273,7 +5273,7 @@
                 <a:ea typeface="Times New Roman"/>
                 <a:cs typeface="Times New Roman"/>
               </a:rPr>
-              <a:t>24 profiles repeat beyond their first occurrence. Without a person identifier, identical values do not prove duplicated people.</a:t>
+              <a:t>24 records repeat the same values as an earlier row. The file has no person ID, so these could represent different people.</a:t>
             </a:r>
           </a:p>
           <a:p xmlns:a="http://schemas.openxmlformats.org/drawingml/2006/main">
@@ -5402,7 +5402,7 @@
                 <a:ea typeface="Times New Roman"/>
                 <a:cs typeface="Times New Roman"/>
               </a:rPr>
-              <a:t>Trim text and replace ? or empty cells with explicit missing values. Retain unknown categories without guessing replacements.</a:t>
+              <a:t>Remove extra spaces and mark ? or blank cells as missing in Pandas. Leave unknown values missing instead of filling them with guesses.</a:t>
             </a:r>
           </a:p>
           <a:p xmlns:a="http://schemas.openxmlformats.org/drawingml/2006/main">
@@ -5430,7 +5430,7 @@
                 <a:ea typeface="Times New Roman"/>
                 <a:cs typeface="Times New Roman"/>
               </a:rPr>
-              <a:t>Convert six numeric fields to integers and nine text fields to categorical data. Validate income labels and education-code agreement.</a:t>
+              <a:t>Change six numeric fields to integers and nine text fields to categorical data. Check that income labels are valid and education codes match their labels.</a:t>
             </a:r>
           </a:p>
           <a:p xmlns:a="http://schemas.openxmlformats.org/drawingml/2006/main">
@@ -5458,7 +5458,7 @@
                 <a:ea typeface="Times New Roman"/>
                 <a:cs typeface="Times New Roman"/>
               </a:rPr>
-              <a:t>Retain all records, including repeated profiles. Document duplicates for later sensitivity checks rather than assuming they are errors.</a:t>
+              <a:t>Keep all records, including repeated rows. Record how many repeat so their effect can be checked in a later project.</a:t>
             </a:r>
           </a:p>
           <a:p xmlns:a="http://schemas.openxmlformats.org/drawingml/2006/main">
@@ -5486,7 +5486,7 @@
                 <a:ea typeface="Times New Roman"/>
                 <a:cs typeface="Times New Roman"/>
               </a:rPr>
-              <a:t>Preserve valid zero capital gains and losses. Retain plausible extreme ages and work hours rather than automatically clipping them.</a:t>
+              <a:t>Keep valid zero capital gains and losses. Keep the observed age and work-hour values because they pass the range checks.</a:t>
             </a:r>
           </a:p>
           <a:p xmlns:a="http://schemas.openxmlformats.org/drawingml/2006/main">
@@ -5514,7 +5514,7 @@
                 <a:ea typeface="Times New Roman"/>
                 <a:cs typeface="Times New Roman"/>
               </a:rPr>
-              <a:t>Create education_group with NumPy and encode income_gt_50k as 1 for above $50,000 and 0 otherwise. Preserve every original field.</a:t>
+              <a:t>Use NumPy to create education_group and income_gt_50k. The income flag is 1 for above $50,000 and 0 for at or below $50,000. Keep every original field.</a:t>
             </a:r>
           </a:p>
         </p:txBody>
@@ -5563,7 +5563,7 @@
           <a:lstStyle xmlns:a="http://schemas.openxmlformats.org/drawingml/2006/main"/>
           <a:p xmlns:a="http://schemas.openxmlformats.org/drawingml/2006/main">
             <a:r>
-              <a:t>Prepare: Readiness and Scope</a:t>
+              <a:t>Prepare: Final Dataset</a:t>
             </a:r>
           </a:p>
         </p:txBody>
@@ -5671,7 +5671,7 @@
                 <a:ea typeface="Times New Roman"/>
                 <a:cs typeface="Times New Roman"/>
               </a:rPr>
-              <a:t>Checks passed for the schema, required values, integer fields, plausible ranges, income categories, and education-code consistency.</a:t>
+              <a:t>Checks passed for column names, required values, numeric ranges, income labels, and matching education codes.</a:t>
             </a:r>
           </a:p>
           <a:p xmlns:a="http://schemas.openxmlformats.org/drawingml/2006/main">
@@ -5699,7 +5699,7 @@
                 <a:ea typeface="Times New Roman"/>
                 <a:cs typeface="Times New Roman"/>
               </a:rPr>
-              <a:t>Unknown ancillary categories remain documented. The data are ready for the planned education comparison, subject to later analytical decisions.</a:t>
+              <a:t>Missing workclass, occupation, and native-country values remain recorded as missing. Education and income are complete for the planned comparison.</a:t>
             </a:r>
           </a:p>
           <a:p xmlns:a="http://schemas.openxmlformats.org/drawingml/2006/main">
@@ -5727,7 +5727,7 @@
                 <a:ea typeface="Times New Roman"/>
                 <a:cs typeface="Times New Roman"/>
               </a:rPr>
-              <a:t>Limitations: historical 1994 data, broad income categories, unweighted sample summaries, and no causal design.</a:t>
+              <a:t>These results describe the 1994 sample, with each row counted equally. They do not show that education causes higher income.</a:t>
             </a:r>
           </a:p>
           <a:p xmlns:a="http://schemas.openxmlformats.org/drawingml/2006/main">
@@ -5755,7 +5755,7 @@
                 <a:ea typeface="Times New Roman"/>
                 <a:cs typeface="Times New Roman"/>
               </a:rPr>
-              <a:t>Micro-Project 1 ends at Prepare. The hypothesis remains untested; Analyze, Report, and Act are reserved for later work.</a:t>
+              <a:t>This project ends at Step 2, Prepare. The hypothesis is still untested. Analyze, Report, and Act come later.</a:t>
             </a:r>
           </a:p>
         </p:txBody>

</xml_diff>